<commit_message>
Publish switching handoff validation and evidence-backed PM findings
Record five fresh-agent GET-only workflows, investigate response counts, and refresh the 16-slide deck with accurate validation boundaries and write-safety claims.

Co-authored-by: Copilot <223556219+Copilot@users.noreply.github.com>
</commit_message>
<xml_diff>
--- a/examples/switching-validation/Catalyst-Center-MCP-Switching.pptx
+++ b/examples/switching-validation/Catalyst-Center-MCP-Switching.pptx
@@ -20,6 +20,7 @@
     <p:sldId id="268" r:id="rId19"/>
     <p:sldId id="269" r:id="rId20"/>
     <p:sldId id="270" r:id="rId21"/>
+    <p:sldId id="271" r:id="rId22"/>
   </p:sldIdLst>
   <p:sldSz cx="12191695" cy="6858000" type="screen4x3"/>
   <p:notesSz cx="6858000" cy="9144000"/>
@@ -3539,7 +3540,7 @@
                 </a:solidFill>
                 <a:latin typeface="Calibri"/>
               </a:rPr>
-              <a:t>Compliance Remediation, End-to-End</a:t>
+              <a:t>Compliance Remediation: Submission and Observed No-Op</a:t>
             </a:r>
           </a:p>
         </p:txBody>
@@ -3932,7 +3933,7 @@
                 </a:solidFill>
                 <a:latin typeface="Calibri"/>
               </a:rPr>
-              <a:t>•  'Nothing to be remediated' (device compliant → no flap)</a:t>
+              <a:t>•  'Nothing to be remediated' in this one test</a:t>
             </a:r>
           </a:p>
           <a:p>
@@ -3951,7 +3952,7 @@
                 </a:solidFill>
                 <a:latin typeface="Calibri"/>
               </a:rPr>
-              <a:t>•  Confirms the write path works safely end-to-end</a:t>
+              <a:t>•  Task outcome checked through direct REST, outside MCP</a:t>
             </a:r>
           </a:p>
         </p:txBody>
@@ -4138,7 +4139,7 @@
                 </a:solidFill>
                 <a:latin typeface="Calibri"/>
               </a:rPr>
-              <a:t>•  On a compliant device it is a safe no-op; on a non-compliant device it pushes config and may flap</a:t>
+              <a:t>•  No configuration-changing remediation was demonstrated; not every category is supported</a:t>
             </a:r>
           </a:p>
           <a:p>
@@ -4157,7 +4158,7 @@
                 </a:solidFill>
                 <a:latin typeface="Calibri"/>
               </a:rPr>
-              <a:t>•  Bind a read-only account to remove write capability entirely for pure visibility use cases</a:t>
+              <a:t>•  No-op is not a safety guarantee; read-only RBAC denies writes, not tool discovery</a:t>
             </a:r>
           </a:p>
         </p:txBody>
@@ -4199,7 +4200,7 @@
                 </a:solidFill>
                 <a:latin typeface="Calibri"/>
               </a:rPr>
-              <a:t>Catalyst Center MCP — Switching Management  |  Technical Marketing  |  Validated on CatC 2.3.7.11</a:t>
+              <a:t>Catalyst Center MCP — Switching Management  |  Technical Marketing  |  Lab evidence: CatC 2.3.7.11</a:t>
             </a:r>
           </a:p>
         </p:txBody>
@@ -5072,7 +5073,7 @@
                 </a:solidFill>
                 <a:latin typeface="Calibri"/>
               </a:rPr>
-              <a:t>Catalyst Center MCP — Switching Management  |  Technical Marketing  |  Validated on CatC 2.3.7.11</a:t>
+              <a:t>Catalyst Center MCP — Switching Management  |  Technical Marketing  |  Lab evidence: CatC 2.3.7.11</a:t>
             </a:r>
           </a:p>
         </p:txBody>
@@ -5529,7 +5530,7 @@
                 </a:solidFill>
                 <a:latin typeface="Calibri"/>
               </a:rPr>
-              <a:t>•  Results are a JSON string nested under 'result' (double-parse)</a:t>
+              <a:t>•  Inspect actual client result structure; decode nested JSON only when needed</a:t>
             </a:r>
           </a:p>
         </p:txBody>
@@ -5796,7 +5797,7 @@
                 </a:solidFill>
                 <a:latin typeface="Calibri"/>
               </a:rPr>
-              <a:t>Catalyst Center MCP — Switching Management  |  Technical Marketing  |  Validated on CatC 2.3.7.11</a:t>
+              <a:t>Catalyst Center MCP — Switching Management  |  Technical Marketing  |  Lab evidence: CatC 2.3.7.11</a:t>
             </a:r>
           </a:p>
         </p:txBody>
@@ -6371,7 +6372,7 @@
                 </a:solidFill>
                 <a:latin typeface="Calibri"/>
               </a:rPr>
-              <a:t>Catalyst Center MCP — Switching Management  |  Technical Marketing  |  Validated on CatC 2.3.7.11</a:t>
+              <a:t>Catalyst Center MCP — Switching Management  |  Technical Marketing  |  Lab evidence: CatC 2.3.7.11</a:t>
             </a:r>
           </a:p>
         </p:txBody>
@@ -6828,7 +6829,7 @@
                 </a:solidFill>
                 <a:latin typeface="Calibri"/>
               </a:rPr>
-              <a:t>•  Release coverage parity — remove tools that 404 on the target release (e.g. fabric readiness)</a:t>
+              <a:t>•  Release compatibility checks — investigate lab 404s before declaring unsupported endpoints</a:t>
             </a:r>
           </a:p>
           <a:p>
@@ -6847,7 +6848,7 @@
                 </a:solidFill>
                 <a:latin typeface="Calibri"/>
               </a:rPr>
-              <a:t>•  Typed/structured output contract (avoid JSON-string-in-'result' double-parsing)</a:t>
+              <a:t>•  Typed output and clear pagination/record-grain contracts; preserve errors and source times</a:t>
             </a:r>
           </a:p>
         </p:txBody>
@@ -6889,7 +6890,7 @@
                 </a:solidFill>
                 <a:latin typeface="Calibri"/>
               </a:rPr>
-              <a:t>Catalyst Center MCP — Switching Management  |  Technical Marketing  |  Validated on CatC 2.3.7.11</a:t>
+              <a:t>Catalyst Center MCP — Switching Management  |  Technical Marketing  |  Lab evidence: CatC 2.3.7.11</a:t>
             </a:r>
           </a:p>
         </p:txBody>
@@ -6963,7 +6964,7 @@
         <p:spPr>
           <a:xfrm>
             <a:off x="0" y="0"/>
-            <a:ext cx="12191695" cy="6858000"/>
+            <a:ext cx="12191695" cy="1051560"/>
           </a:xfrm>
           <a:prstGeom prst="rect">
             <a:avLst/>
@@ -7006,7 +7007,7 @@
         </p:nvSpPr>
         <p:spPr>
           <a:xfrm>
-            <a:off x="0" y="1645920"/>
+            <a:off x="0" y="1051560"/>
             <a:ext cx="12191695" cy="54864"/>
           </a:xfrm>
           <a:prstGeom prst="rect">
@@ -7050,8 +7051,8 @@
         </p:nvSpPr>
         <p:spPr>
           <a:xfrm>
-            <a:off x="640080" y="640080"/>
-            <a:ext cx="10972800" cy="914400"/>
+            <a:off x="457200" y="128016"/>
+            <a:ext cx="10972800" cy="320040"/>
           </a:xfrm>
           <a:prstGeom prst="rect">
             <a:avLst/>
@@ -7073,13 +7074,13 @@
               </a:spcAft>
             </a:pPr>
             <a:r>
-              <a:rPr sz="4000" b="1">
-                <a:solidFill>
-                  <a:srgbClr val="FFFFFF"/>
-                </a:solidFill>
-                <a:latin typeface="Calibri"/>
-              </a:rPr>
-              <a:t>Summary &amp; Next Steps</a:t>
+              <a:rPr sz="1200" b="1">
+                <a:solidFill>
+                  <a:srgbClr val="00BCEB"/>
+                </a:solidFill>
+                <a:latin typeface="Calibri"/>
+              </a:rPr>
+              <a:t>FOLLOW-UP VALIDATION</a:t>
             </a:r>
           </a:p>
         </p:txBody>
@@ -7092,8 +7093,138 @@
         </p:nvSpPr>
         <p:spPr>
           <a:xfrm>
-            <a:off x="640080" y="2011680"/>
-            <a:ext cx="10972800" cy="4023360"/>
+            <a:off x="457200" y="402336"/>
+            <a:ext cx="11247120" cy="603504"/>
+          </a:xfrm>
+          <a:prstGeom prst="rect">
+            <a:avLst/>
+          </a:prstGeom>
+          <a:noFill/>
+        </p:spPr>
+        <p:txBody>
+          <a:bodyPr wrap="square" anchor="ctr" lIns="50800" rIns="50800" tIns="25400" bIns="25400">
+            <a:spAutoFit/>
+          </a:bodyPr>
+          <a:lstStyle/>
+          <a:p>
+            <a:pPr algn="l">
+              <a:spcBef>
+                <a:spcPts val="0"/>
+              </a:spcBef>
+              <a:spcAft>
+                <a:spcPts val="400"/>
+              </a:spcAft>
+            </a:pPr>
+            <a:r>
+              <a:rPr sz="2600" b="1">
+                <a:solidFill>
+                  <a:srgbClr val="FFFFFF"/>
+                </a:solidFill>
+                <a:latin typeface="Calibri"/>
+              </a:rPr>
+              <a:t>Evidence Strength and Open Questions</a:t>
+            </a:r>
+          </a:p>
+        </p:txBody>
+      </p:sp>
+      <p:sp>
+        <p:nvSpPr>
+          <p:cNvPr id="6" name="Rectangle 5"/>
+          <p:cNvSpPr/>
+          <p:nvPr/>
+        </p:nvSpPr>
+        <p:spPr>
+          <a:xfrm>
+            <a:off x="457200" y="1371600"/>
+            <a:ext cx="5577840" cy="4480560"/>
+          </a:xfrm>
+          <a:prstGeom prst="rect">
+            <a:avLst/>
+          </a:prstGeom>
+          <a:solidFill>
+            <a:srgbClr val="F2F6FA"/>
+          </a:solidFill>
+          <a:ln>
+            <a:noFill/>
+          </a:ln>
+          <a:effectLst/>
+        </p:spPr>
+        <p:style>
+          <a:lnRef idx="1">
+            <a:schemeClr val="accent1"/>
+          </a:lnRef>
+          <a:fillRef idx="3">
+            <a:schemeClr val="accent1"/>
+          </a:fillRef>
+          <a:effectRef idx="2">
+            <a:schemeClr val="accent1"/>
+          </a:effectRef>
+          <a:fontRef idx="minor">
+            <a:schemeClr val="lt1"/>
+          </a:fontRef>
+        </p:style>
+        <p:txBody>
+          <a:bodyPr rtlCol="0" anchor="ctr"/>
+          <a:lstStyle/>
+          <a:p>
+            <a:pPr algn="ctr"/>
+          </a:p>
+        </p:txBody>
+      </p:sp>
+      <p:sp>
+        <p:nvSpPr>
+          <p:cNvPr id="7" name="Rectangle 6"/>
+          <p:cNvSpPr/>
+          <p:nvPr/>
+        </p:nvSpPr>
+        <p:spPr>
+          <a:xfrm>
+            <a:off x="457200" y="1371600"/>
+            <a:ext cx="82296" cy="4480560"/>
+          </a:xfrm>
+          <a:prstGeom prst="rect">
+            <a:avLst/>
+          </a:prstGeom>
+          <a:solidFill>
+            <a:srgbClr val="00519E"/>
+          </a:solidFill>
+          <a:ln>
+            <a:noFill/>
+          </a:ln>
+          <a:effectLst/>
+        </p:spPr>
+        <p:style>
+          <a:lnRef idx="1">
+            <a:schemeClr val="accent1"/>
+          </a:lnRef>
+          <a:fillRef idx="3">
+            <a:schemeClr val="accent1"/>
+          </a:fillRef>
+          <a:effectRef idx="2">
+            <a:schemeClr val="accent1"/>
+          </a:effectRef>
+          <a:fontRef idx="minor">
+            <a:schemeClr val="lt1"/>
+          </a:fontRef>
+        </p:style>
+        <p:txBody>
+          <a:bodyPr rtlCol="0" anchor="ctr"/>
+          <a:lstStyle/>
+          <a:p>
+            <a:pPr algn="ctr"/>
+          </a:p>
+        </p:txBody>
+      </p:sp>
+      <p:sp>
+        <p:nvSpPr>
+          <p:cNvPr id="8" name="TextBox 7"/>
+          <p:cNvSpPr txBox="1"/>
+          <p:nvPr/>
+        </p:nvSpPr>
+        <p:spPr>
+          <a:xfrm>
+            <a:off x="658368" y="1481328"/>
+            <a:ext cx="5257800" cy="4297680"/>
           </a:xfrm>
           <a:prstGeom prst="rect">
             <a:avLst/>
@@ -7111,88 +7242,195 @@
                 <a:spcPts val="0"/>
               </a:spcBef>
               <a:spcAft>
-                <a:spcPts val="1600"/>
-              </a:spcAft>
-            </a:pPr>
-            <a:r>
-              <a:rPr sz="1800" b="0">
-                <a:solidFill>
-                  <a:srgbClr val="DDE8F4"/>
-                </a:solidFill>
-                <a:latin typeface="Calibri"/>
-              </a:rPr>
-              <a:t>Today, the official Catalyst Center MCP is a strong READ/assurance surface for switching — inventory, interfaces, VLANs, running-config, health, compliance, lifecycle.</a:t>
-            </a:r>
-          </a:p>
-          <a:p>
-            <a:pPr algn="l">
-              <a:spcBef>
-                <a:spcPts val="0"/>
-              </a:spcBef>
-              <a:spcAft>
-                <a:spcPts val="1600"/>
-              </a:spcAft>
-            </a:pPr>
-            <a:r>
-              <a:rPr sz="1800" b="0">
-                <a:solidFill>
-                  <a:srgbClr val="DDE8F4"/>
-                </a:solidFill>
-                <a:latin typeface="Calibri"/>
-              </a:rPr>
-              <a:t>The only write action on 2.3.7.11 is compliance remediation; all other switching changes are not yet exposed.</a:t>
-            </a:r>
-          </a:p>
-          <a:p>
-            <a:pPr algn="l">
-              <a:spcBef>
-                <a:spcPts val="0"/>
-              </a:spcBef>
-              <a:spcAft>
-                <a:spcPts val="1600"/>
-              </a:spcAft>
-            </a:pPr>
-            <a:r>
-              <a:rPr sz="1800" b="1">
-                <a:solidFill>
-                  <a:srgbClr val="00BCEB"/>
-                </a:solidFill>
-                <a:latin typeface="Calibri"/>
-              </a:rPr>
-              <a:t>Use it now for troubleshooting, audit, and compliance; drive config-change enhancements through PM.</a:t>
-            </a:r>
-          </a:p>
-          <a:p>
-            <a:pPr algn="l">
-              <a:spcBef>
-                <a:spcPts val="0"/>
-              </a:spcBef>
-              <a:spcAft>
-                <a:spcPts val="1600"/>
-              </a:spcAft>
-            </a:pPr>
-            <a:r>
-              <a:rPr sz="1600" b="0">
-                <a:solidFill>
-                  <a:srgbClr val="C9DAEE"/>
-                </a:solidFill>
-                <a:latin typeface="Calibri"/>
-              </a:rPr>
-              <a:t>Deliverables: capability matrix · client-agnostic switching playbook · this deck.</a:t>
-            </a:r>
-          </a:p>
-        </p:txBody>
-      </p:sp>
-      <p:sp>
-        <p:nvSpPr>
-          <p:cNvPr id="6" name="TextBox 5"/>
+                <a:spcPts val="500"/>
+              </a:spcAft>
+            </a:pPr>
+            <a:r>
+              <a:rPr sz="1400" b="1">
+                <a:solidFill>
+                  <a:srgbClr val="0D274D"/>
+                </a:solidFill>
+                <a:latin typeface="Calibri"/>
+              </a:rPr>
+              <a:t>Reproduced GET response observations</a:t>
+            </a:r>
+          </a:p>
+          <a:p>
+            <a:pPr algn="l">
+              <a:spcBef>
+                <a:spcPts val="0"/>
+              </a:spcBef>
+              <a:spcAft>
+                <a:spcPts val="500"/>
+              </a:spcAft>
+            </a:pPr>
+            <a:r>
+              <a:rPr sz="1150" b="0">
+                <a:solidFill>
+                  <a:srgbClr val="535A63"/>
+                </a:solidFill>
+                <a:latin typeface="Calibri"/>
+              </a:rPr>
+              <a:t>•  Health: 61 rows, 30 unique UUIDs, totalCount=30; repeated rows equal within UUID groups</a:t>
+            </a:r>
+          </a:p>
+          <a:p>
+            <a:pPr algn="l">
+              <a:spcBef>
+                <a:spcPts val="0"/>
+              </a:spcBef>
+              <a:spcAft>
+                <a:spcPts val="500"/>
+              </a:spcAft>
+            </a:pPr>
+            <a:r>
+              <a:rPr sz="1150" b="0">
+                <a:solidFill>
+                  <a:srgbClr val="535A63"/>
+                </a:solidFill>
+                <a:latin typeface="Calibri"/>
+              </a:rPr>
+              <a:t>•  Health ten-row requests overlap; preserve page boundaries rather than assuming coverage</a:t>
+            </a:r>
+          </a:p>
+          <a:p>
+            <a:pPr algn="l">
+              <a:spcBef>
+                <a:spcPts val="0"/>
+              </a:spcBef>
+              <a:spcAft>
+                <a:spcPts val="500"/>
+              </a:spcAft>
+            </a:pPr>
+            <a:r>
+              <a:rPr sz="1150" b="0">
+                <a:solidFill>
+                  <a:srgbClr val="535A63"/>
+                </a:solidFill>
+                <a:latin typeface="Calibri"/>
+              </a:rPr>
+              <a:t>•  Compliance: 26 category records for 17 devices; repeated device IDs are not necessarily duplicate findings</a:t>
+            </a:r>
+          </a:p>
+          <a:p>
+            <a:pPr algn="l">
+              <a:spcBef>
+                <a:spcPts val="0"/>
+              </a:spcBef>
+              <a:spcAft>
+                <a:spcPts val="500"/>
+              </a:spcAft>
+            </a:pPr>
+            <a:r>
+              <a:rPr sz="1150" b="0">
+                <a:solidFill>
+                  <a:srgbClr val="535A63"/>
+                </a:solidFill>
+                <a:latin typeface="Calibri"/>
+              </a:rPr>
+              <a:t>•  Six bounded GET probes saved with arguments, timestamps and structured payloads</a:t>
+            </a:r>
+          </a:p>
+        </p:txBody>
+      </p:sp>
+      <p:sp>
+        <p:nvSpPr>
+          <p:cNvPr id="9" name="Rectangle 8"/>
+          <p:cNvSpPr/>
+          <p:nvPr/>
+        </p:nvSpPr>
+        <p:spPr>
+          <a:xfrm>
+            <a:off x="6217920" y="1371600"/>
+            <a:ext cx="5486400" cy="4480560"/>
+          </a:xfrm>
+          <a:prstGeom prst="rect">
+            <a:avLst/>
+          </a:prstGeom>
+          <a:solidFill>
+            <a:srgbClr val="F2F6FA"/>
+          </a:solidFill>
+          <a:ln>
+            <a:noFill/>
+          </a:ln>
+          <a:effectLst/>
+        </p:spPr>
+        <p:style>
+          <a:lnRef idx="1">
+            <a:schemeClr val="accent1"/>
+          </a:lnRef>
+          <a:fillRef idx="3">
+            <a:schemeClr val="accent1"/>
+          </a:fillRef>
+          <a:effectRef idx="2">
+            <a:schemeClr val="accent1"/>
+          </a:effectRef>
+          <a:fontRef idx="minor">
+            <a:schemeClr val="lt1"/>
+          </a:fontRef>
+        </p:style>
+        <p:txBody>
+          <a:bodyPr rtlCol="0" anchor="ctr"/>
+          <a:lstStyle/>
+          <a:p>
+            <a:pPr algn="ctr"/>
+          </a:p>
+        </p:txBody>
+      </p:sp>
+      <p:sp>
+        <p:nvSpPr>
+          <p:cNvPr id="10" name="Rectangle 9"/>
+          <p:cNvSpPr/>
+          <p:nvPr/>
+        </p:nvSpPr>
+        <p:spPr>
+          <a:xfrm>
+            <a:off x="6217920" y="1371600"/>
+            <a:ext cx="82296" cy="4480560"/>
+          </a:xfrm>
+          <a:prstGeom prst="rect">
+            <a:avLst/>
+          </a:prstGeom>
+          <a:solidFill>
+            <a:srgbClr val="C87A00"/>
+          </a:solidFill>
+          <a:ln>
+            <a:noFill/>
+          </a:ln>
+          <a:effectLst/>
+        </p:spPr>
+        <p:style>
+          <a:lnRef idx="1">
+            <a:schemeClr val="accent1"/>
+          </a:lnRef>
+          <a:fillRef idx="3">
+            <a:schemeClr val="accent1"/>
+          </a:fillRef>
+          <a:effectRef idx="2">
+            <a:schemeClr val="accent1"/>
+          </a:effectRef>
+          <a:fontRef idx="minor">
+            <a:schemeClr val="lt1"/>
+          </a:fontRef>
+        </p:style>
+        <p:txBody>
+          <a:bodyPr rtlCol="0" anchor="ctr"/>
+          <a:lstStyle/>
+          <a:p>
+            <a:pPr algn="ctr"/>
+          </a:p>
+        </p:txBody>
+      </p:sp>
+      <p:sp>
+        <p:nvSpPr>
+          <p:cNvPr id="11" name="TextBox 10"/>
           <p:cNvSpPr txBox="1"/>
           <p:nvPr/>
         </p:nvSpPr>
         <p:spPr>
           <a:xfrm>
-            <a:off x="457200" y="6446520"/>
-            <a:ext cx="8229600" cy="320040"/>
+            <a:off x="6419088" y="1481328"/>
+            <a:ext cx="5166360" cy="4297680"/>
           </a:xfrm>
           <a:prstGeom prst="rect">
             <a:avLst/>
@@ -7210,31 +7448,107 @@
                 <a:spcPts val="0"/>
               </a:spcBef>
               <a:spcAft>
-                <a:spcPts val="400"/>
-              </a:spcAft>
-            </a:pPr>
-            <a:r>
-              <a:rPr sz="900" b="0">
+                <a:spcPts val="500"/>
+              </a:spcAft>
+            </a:pPr>
+            <a:r>
+              <a:rPr sz="1400" b="1">
+                <a:solidFill>
+                  <a:srgbClr val="0D274D"/>
+                </a:solidFill>
+                <a:latin typeface="Calibri"/>
+              </a:rPr>
+              <a:t>Claims and next decisions</a:t>
+            </a:r>
+          </a:p>
+          <a:p>
+            <a:pPr algn="l">
+              <a:spcBef>
+                <a:spcPts val="0"/>
+              </a:spcBef>
+              <a:spcAft>
+                <a:spcPts val="500"/>
+              </a:spcAft>
+            </a:pPr>
+            <a:r>
+              <a:rPr sz="1150" b="0">
                 <a:solidFill>
                   <a:srgbClr val="535A63"/>
                 </a:solidFill>
                 <a:latin typeface="Calibri"/>
               </a:rPr>
-              <a:t>Catalyst Center MCP — Switching Management  |  Technical Marketing  |  Validated on CatC 2.3.7.11</a:t>
-            </a:r>
-          </a:p>
-        </p:txBody>
-      </p:sp>
-      <p:sp>
-        <p:nvSpPr>
-          <p:cNvPr id="7" name="TextBox 6"/>
+              <a:t>•  The original 26 examples have narrative observations, not complete acceptance traces</a:t>
+            </a:r>
+          </a:p>
+          <a:p>
+            <a:pPr algn="l">
+              <a:spcBef>
+                <a:spcPts val="0"/>
+              </a:spcBef>
+              <a:spcAft>
+                <a:spcPts val="500"/>
+              </a:spcAft>
+            </a:pPr>
+            <a:r>
+              <a:rPr sz="1150" b="0">
+                <a:solidFill>
+                  <a:srgbClr val="535A63"/>
+                </a:solidFill>
+                <a:latin typeface="Calibri"/>
+              </a:rPr>
+              <a:t>•  Five handoff workflows passed: 46 GET calls, 18 switches, 52 interfaces, 14 site members; Python client only</a:t>
+            </a:r>
+          </a:p>
+          <a:p>
+            <a:pPr algn="l">
+              <a:spcBef>
+                <a:spcPts val="0"/>
+              </a:spcBef>
+              <a:spcAft>
+                <a:spcPts val="500"/>
+              </a:spcAft>
+            </a:pPr>
+            <a:r>
+              <a:rPr sz="1150" b="0">
+                <a:solidFill>
+                  <a:srgbClr val="535A63"/>
+                </a:solidFill>
+                <a:latin typeface="Calibri"/>
+              </a:rPr>
+              <a:t>•  No configuration-changing remediation demonstrated; current review stops before execution</a:t>
+            </a:r>
+          </a:p>
+          <a:p>
+            <a:pPr algn="l">
+              <a:spcBef>
+                <a:spcPts val="0"/>
+              </a:spcBef>
+              <a:spcAft>
+                <a:spcPts val="500"/>
+              </a:spcAft>
+            </a:pPr>
+            <a:r>
+              <a:rPr sz="1150" b="0">
+                <a:solidFill>
+                  <a:srgbClr val="535A63"/>
+                </a:solidFill>
+                <a:latin typeface="Calibri"/>
+              </a:rPr>
+              <a:t>•  Separate missing tools, lab endpoint failures, data-contract questions and agent usability</a:t>
+            </a:r>
+          </a:p>
+        </p:txBody>
+      </p:sp>
+      <p:sp>
+        <p:nvSpPr>
+          <p:cNvPr id="12" name="TextBox 11"/>
           <p:cNvSpPr txBox="1"/>
           <p:nvPr/>
         </p:nvSpPr>
         <p:spPr>
           <a:xfrm>
-            <a:off x="11247120" y="6446520"/>
-            <a:ext cx="731520" cy="320040"/>
+            <a:off x="457200" y="6446520"/>
+            <a:ext cx="8229600" cy="320040"/>
           </a:xfrm>
           <a:prstGeom prst="rect">
             <a:avLst/>
@@ -7247,6 +7561,48 @@
           </a:bodyPr>
           <a:lstStyle/>
           <a:p>
+            <a:pPr algn="l">
+              <a:spcBef>
+                <a:spcPts val="0"/>
+              </a:spcBef>
+              <a:spcAft>
+                <a:spcPts val="400"/>
+              </a:spcAft>
+            </a:pPr>
+            <a:r>
+              <a:rPr sz="900" b="0">
+                <a:solidFill>
+                  <a:srgbClr val="535A63"/>
+                </a:solidFill>
+                <a:latin typeface="Calibri"/>
+              </a:rPr>
+              <a:t>Catalyst Center MCP — Switching Management  |  Technical Marketing  |  Lab evidence: CatC 2.3.7.11</a:t>
+            </a:r>
+          </a:p>
+        </p:txBody>
+      </p:sp>
+      <p:sp>
+        <p:nvSpPr>
+          <p:cNvPr id="13" name="TextBox 12"/>
+          <p:cNvSpPr txBox="1"/>
+          <p:nvPr/>
+        </p:nvSpPr>
+        <p:spPr>
+          <a:xfrm>
+            <a:off x="11247120" y="6446520"/>
+            <a:ext cx="731520" cy="320040"/>
+          </a:xfrm>
+          <a:prstGeom prst="rect">
+            <a:avLst/>
+          </a:prstGeom>
+          <a:noFill/>
+        </p:spPr>
+        <p:txBody>
+          <a:bodyPr wrap="square" anchor="t" lIns="50800" rIns="50800" tIns="25400" bIns="25400">
+            <a:spAutoFit/>
+          </a:bodyPr>
+          <a:lstStyle/>
+          <a:p>
             <a:pPr algn="r">
               <a:spcBef>
                 <a:spcPts val="0"/>
@@ -7263,6 +7619,337 @@
                 <a:latin typeface="Calibri"/>
               </a:rPr>
               <a:t>15</a:t>
+            </a:r>
+          </a:p>
+        </p:txBody>
+      </p:sp>
+    </p:spTree>
+  </p:cSld>
+  <p:clrMapOvr>
+    <a:masterClrMapping/>
+  </p:clrMapOvr>
+</p:sld>
+</file>
+
+<file path=ppt/slides/slide16.xml><?xml version="1.0" encoding="utf-8"?>
+<p:sld xmlns:a="http://schemas.openxmlformats.org/drawingml/2006/main" xmlns:p="http://schemas.openxmlformats.org/presentationml/2006/main" xmlns:r="http://schemas.openxmlformats.org/officeDocument/2006/relationships">
+  <p:cSld>
+    <p:spTree>
+      <p:nvGrpSpPr>
+        <p:cNvPr id="1" name=""/>
+        <p:cNvGrpSpPr/>
+        <p:nvPr/>
+      </p:nvGrpSpPr>
+      <p:grpSpPr/>
+      <p:sp>
+        <p:nvSpPr>
+          <p:cNvPr id="2" name="Rectangle 1"/>
+          <p:cNvSpPr/>
+          <p:nvPr/>
+        </p:nvSpPr>
+        <p:spPr>
+          <a:xfrm>
+            <a:off x="0" y="0"/>
+            <a:ext cx="12191695" cy="6858000"/>
+          </a:xfrm>
+          <a:prstGeom prst="rect">
+            <a:avLst/>
+          </a:prstGeom>
+          <a:solidFill>
+            <a:srgbClr val="0D274D"/>
+          </a:solidFill>
+          <a:ln>
+            <a:noFill/>
+          </a:ln>
+          <a:effectLst/>
+        </p:spPr>
+        <p:style>
+          <a:lnRef idx="1">
+            <a:schemeClr val="accent1"/>
+          </a:lnRef>
+          <a:fillRef idx="3">
+            <a:schemeClr val="accent1"/>
+          </a:fillRef>
+          <a:effectRef idx="2">
+            <a:schemeClr val="accent1"/>
+          </a:effectRef>
+          <a:fontRef idx="minor">
+            <a:schemeClr val="lt1"/>
+          </a:fontRef>
+        </p:style>
+        <p:txBody>
+          <a:bodyPr rtlCol="0" anchor="ctr"/>
+          <a:lstStyle/>
+          <a:p>
+            <a:pPr algn="ctr"/>
+          </a:p>
+        </p:txBody>
+      </p:sp>
+      <p:sp>
+        <p:nvSpPr>
+          <p:cNvPr id="3" name="Rectangle 2"/>
+          <p:cNvSpPr/>
+          <p:nvPr/>
+        </p:nvSpPr>
+        <p:spPr>
+          <a:xfrm>
+            <a:off x="0" y="1645920"/>
+            <a:ext cx="12191695" cy="54864"/>
+          </a:xfrm>
+          <a:prstGeom prst="rect">
+            <a:avLst/>
+          </a:prstGeom>
+          <a:solidFill>
+            <a:srgbClr val="00BCEB"/>
+          </a:solidFill>
+          <a:ln>
+            <a:noFill/>
+          </a:ln>
+          <a:effectLst/>
+        </p:spPr>
+        <p:style>
+          <a:lnRef idx="1">
+            <a:schemeClr val="accent1"/>
+          </a:lnRef>
+          <a:fillRef idx="3">
+            <a:schemeClr val="accent1"/>
+          </a:fillRef>
+          <a:effectRef idx="2">
+            <a:schemeClr val="accent1"/>
+          </a:effectRef>
+          <a:fontRef idx="minor">
+            <a:schemeClr val="lt1"/>
+          </a:fontRef>
+        </p:style>
+        <p:txBody>
+          <a:bodyPr rtlCol="0" anchor="ctr"/>
+          <a:lstStyle/>
+          <a:p>
+            <a:pPr algn="ctr"/>
+          </a:p>
+        </p:txBody>
+      </p:sp>
+      <p:sp>
+        <p:nvSpPr>
+          <p:cNvPr id="4" name="TextBox 3"/>
+          <p:cNvSpPr txBox="1"/>
+          <p:nvPr/>
+        </p:nvSpPr>
+        <p:spPr>
+          <a:xfrm>
+            <a:off x="640080" y="640080"/>
+            <a:ext cx="10972800" cy="914400"/>
+          </a:xfrm>
+          <a:prstGeom prst="rect">
+            <a:avLst/>
+          </a:prstGeom>
+          <a:noFill/>
+        </p:spPr>
+        <p:txBody>
+          <a:bodyPr wrap="square" anchor="t" lIns="50800" rIns="50800" tIns="25400" bIns="25400">
+            <a:spAutoFit/>
+          </a:bodyPr>
+          <a:lstStyle/>
+          <a:p>
+            <a:pPr algn="l">
+              <a:spcBef>
+                <a:spcPts val="0"/>
+              </a:spcBef>
+              <a:spcAft>
+                <a:spcPts val="400"/>
+              </a:spcAft>
+            </a:pPr>
+            <a:r>
+              <a:rPr sz="4000" b="1">
+                <a:solidFill>
+                  <a:srgbClr val="FFFFFF"/>
+                </a:solidFill>
+                <a:latin typeface="Calibri"/>
+              </a:rPr>
+              <a:t>Summary &amp; Next Steps</a:t>
+            </a:r>
+          </a:p>
+        </p:txBody>
+      </p:sp>
+      <p:sp>
+        <p:nvSpPr>
+          <p:cNvPr id="5" name="TextBox 4"/>
+          <p:cNvSpPr txBox="1"/>
+          <p:nvPr/>
+        </p:nvSpPr>
+        <p:spPr>
+          <a:xfrm>
+            <a:off x="640080" y="2011680"/>
+            <a:ext cx="10972800" cy="4023360"/>
+          </a:xfrm>
+          <a:prstGeom prst="rect">
+            <a:avLst/>
+          </a:prstGeom>
+          <a:noFill/>
+        </p:spPr>
+        <p:txBody>
+          <a:bodyPr wrap="square" anchor="t" lIns="50800" rIns="50800" tIns="25400" bIns="25400">
+            <a:spAutoFit/>
+          </a:bodyPr>
+          <a:lstStyle/>
+          <a:p>
+            <a:pPr algn="l">
+              <a:spcBef>
+                <a:spcPts val="0"/>
+              </a:spcBef>
+              <a:spcAft>
+                <a:spcPts val="1600"/>
+              </a:spcAft>
+            </a:pPr>
+            <a:r>
+              <a:rPr sz="1800" b="0">
+                <a:solidFill>
+                  <a:srgbClr val="DDE8F4"/>
+                </a:solidFill>
+                <a:latin typeface="Calibri"/>
+              </a:rPr>
+              <a:t>Today, the official Catalyst Center MCP is a strong READ/assurance surface for switching — inventory, interfaces, VLANs, running-config, health, compliance, lifecycle.</a:t>
+            </a:r>
+          </a:p>
+          <a:p>
+            <a:pPr algn="l">
+              <a:spcBef>
+                <a:spcPts val="0"/>
+              </a:spcBef>
+              <a:spcAft>
+                <a:spcPts val="1600"/>
+              </a:spcAft>
+            </a:pPr>
+            <a:r>
+              <a:rPr sz="1800" b="0">
+                <a:solidFill>
+                  <a:srgbClr val="DDE8F4"/>
+                </a:solidFill>
+                <a:latin typeface="Calibri"/>
+              </a:rPr>
+              <a:t>The only write action on 2.3.7.11 is compliance remediation; all other switching changes are not yet exposed.</a:t>
+            </a:r>
+          </a:p>
+          <a:p>
+            <a:pPr algn="l">
+              <a:spcBef>
+                <a:spcPts val="0"/>
+              </a:spcBef>
+              <a:spcAft>
+                <a:spcPts val="1600"/>
+              </a:spcAft>
+            </a:pPr>
+            <a:r>
+              <a:rPr sz="1800" b="1">
+                <a:solidFill>
+                  <a:srgbClr val="00BCEB"/>
+                </a:solidFill>
+                <a:latin typeface="Calibri"/>
+              </a:rPr>
+              <a:t>Use it now for troubleshooting, audit, and compliance; drive config-change enhancements through PM.</a:t>
+            </a:r>
+          </a:p>
+          <a:p>
+            <a:pPr algn="l">
+              <a:spcBef>
+                <a:spcPts val="0"/>
+              </a:spcBef>
+              <a:spcAft>
+                <a:spcPts val="1600"/>
+              </a:spcAft>
+            </a:pPr>
+            <a:r>
+              <a:rPr sz="1600" b="0">
+                <a:solidFill>
+                  <a:srgbClr val="C9DAEE"/>
+                </a:solidFill>
+                <a:latin typeface="Calibri"/>
+              </a:rPr>
+              <a:t>Deliverables: capability matrix · client-agnostic switching playbook · this deck.</a:t>
+            </a:r>
+          </a:p>
+        </p:txBody>
+      </p:sp>
+      <p:sp>
+        <p:nvSpPr>
+          <p:cNvPr id="6" name="TextBox 5"/>
+          <p:cNvSpPr txBox="1"/>
+          <p:nvPr/>
+        </p:nvSpPr>
+        <p:spPr>
+          <a:xfrm>
+            <a:off x="457200" y="6446520"/>
+            <a:ext cx="8229600" cy="320040"/>
+          </a:xfrm>
+          <a:prstGeom prst="rect">
+            <a:avLst/>
+          </a:prstGeom>
+          <a:noFill/>
+        </p:spPr>
+        <p:txBody>
+          <a:bodyPr wrap="square" anchor="t" lIns="50800" rIns="50800" tIns="25400" bIns="25400">
+            <a:spAutoFit/>
+          </a:bodyPr>
+          <a:lstStyle/>
+          <a:p>
+            <a:pPr algn="l">
+              <a:spcBef>
+                <a:spcPts val="0"/>
+              </a:spcBef>
+              <a:spcAft>
+                <a:spcPts val="400"/>
+              </a:spcAft>
+            </a:pPr>
+            <a:r>
+              <a:rPr sz="900" b="0">
+                <a:solidFill>
+                  <a:srgbClr val="535A63"/>
+                </a:solidFill>
+                <a:latin typeface="Calibri"/>
+              </a:rPr>
+              <a:t>Catalyst Center MCP — Switching Management  |  Technical Marketing  |  Lab evidence: CatC 2.3.7.11</a:t>
+            </a:r>
+          </a:p>
+        </p:txBody>
+      </p:sp>
+      <p:sp>
+        <p:nvSpPr>
+          <p:cNvPr id="7" name="TextBox 6"/>
+          <p:cNvSpPr txBox="1"/>
+          <p:nvPr/>
+        </p:nvSpPr>
+        <p:spPr>
+          <a:xfrm>
+            <a:off x="11247120" y="6446520"/>
+            <a:ext cx="731520" cy="320040"/>
+          </a:xfrm>
+          <a:prstGeom prst="rect">
+            <a:avLst/>
+          </a:prstGeom>
+          <a:noFill/>
+        </p:spPr>
+        <p:txBody>
+          <a:bodyPr wrap="square" anchor="t" lIns="50800" rIns="50800" tIns="25400" bIns="25400">
+            <a:spAutoFit/>
+          </a:bodyPr>
+          <a:lstStyle/>
+          <a:p>
+            <a:pPr algn="r">
+              <a:spcBef>
+                <a:spcPts val="0"/>
+              </a:spcBef>
+              <a:spcAft>
+                <a:spcPts val="400"/>
+              </a:spcAft>
+            </a:pPr>
+            <a:r>
+              <a:rPr sz="900" b="0">
+                <a:solidFill>
+                  <a:srgbClr val="535A63"/>
+                </a:solidFill>
+                <a:latin typeface="Calibri"/>
+              </a:rPr>
+              <a:t>16</a:t>
             </a:r>
           </a:p>
         </p:txBody>
@@ -7845,7 +8532,7 @@
                 </a:solidFill>
                 <a:latin typeface="Calibri"/>
               </a:rPr>
-              <a:t>•  The one write path, end-to-end</a:t>
+              <a:t>•  Write submission and observed no-op outcome</a:t>
             </a:r>
           </a:p>
           <a:p>
@@ -7944,7 +8631,7 @@
                 </a:solidFill>
                 <a:latin typeface="Calibri"/>
               </a:rPr>
-              <a:t>Catalyst Center MCP — Switching Management  |  Technical Marketing  |  Validated on CatC 2.3.7.11</a:t>
+              <a:t>Catalyst Center MCP — Switching Management  |  Technical Marketing  |  Lab evidence: CatC 2.3.7.11</a:t>
             </a:r>
           </a:p>
         </p:txBody>
@@ -8779,7 +9466,7 @@
                 </a:solidFill>
                 <a:latin typeface="Calibri"/>
               </a:rPr>
-              <a:t>Catalyst Center MCP — Switching Management  |  Technical Marketing  |  Validated on CatC 2.3.7.11</a:t>
+              <a:t>Catalyst Center MCP — Switching Management  |  Technical Marketing  |  Lab evidence: CatC 2.3.7.11</a:t>
             </a:r>
           </a:p>
         </p:txBody>
@@ -9643,7 +10330,7 @@
                 </a:solidFill>
                 <a:latin typeface="Calibri"/>
               </a:rPr>
-              <a:t>Catalyst Center MCP — Switching Management  |  Technical Marketing  |  Validated on CatC 2.3.7.11</a:t>
+              <a:t>Catalyst Center MCP — Switching Management  |  Technical Marketing  |  Lab evidence: CatC 2.3.7.11</a:t>
             </a:r>
           </a:p>
         </p:txBody>
@@ -11999,7 +12686,7 @@
                 </a:solidFill>
                 <a:latin typeface="Calibri"/>
               </a:rPr>
-              <a:t>Catalyst Center MCP — Switching Management  |  Technical Marketing  |  Validated on CatC 2.3.7.11</a:t>
+              <a:t>Catalyst Center MCP — Switching Management  |  Technical Marketing  |  Lab evidence: CatC 2.3.7.11</a:t>
             </a:r>
           </a:p>
         </p:txBody>
@@ -12803,7 +13490,7 @@
                 </a:solidFill>
                 <a:latin typeface="Calibri"/>
               </a:rPr>
-              <a:t>Catalyst Center MCP — Switching Management  |  Technical Marketing  |  Validated on CatC 2.3.7.11</a:t>
+              <a:t>Catalyst Center MCP — Switching Management  |  Technical Marketing  |  Lab evidence: CatC 2.3.7.11</a:t>
             </a:r>
           </a:p>
         </p:txBody>
@@ -13825,7 +14512,7 @@
                 </a:solidFill>
                 <a:latin typeface="Calibri"/>
               </a:rPr>
-              <a:t>Catalyst Center MCP — Switching Management  |  Technical Marketing  |  Validated on CatC 2.3.7.11</a:t>
+              <a:t>Catalyst Center MCP — Switching Management  |  Technical Marketing  |  Lab evidence: CatC 2.3.7.11</a:t>
             </a:r>
           </a:p>
         </p:txBody>
@@ -14057,7 +14744,7 @@
                 </a:solidFill>
                 <a:latin typeface="Calibri"/>
               </a:rPr>
-              <a:t>Every GET Tool Exercised Live (514)</a:t>
+              <a:t>514 GET Definitions: 437 Invoked, 77 Skipped</a:t>
             </a:r>
           </a:p>
         </p:txBody>
@@ -14185,7 +14872,7 @@
                 </a:solidFill>
                 <a:latin typeface="Calibri"/>
               </a:rPr>
-              <a:t>returned real data</a:t>
+              <a:t>classifier: OK</a:t>
             </a:r>
           </a:p>
         </p:txBody>
@@ -14313,7 +15000,7 @@
                 </a:solidFill>
                 <a:latin typeface="Calibri"/>
               </a:rPr>
-              <a:t>valid but empty</a:t>
+              <a:t>classifier: EMPTY</a:t>
             </a:r>
           </a:p>
         </p:txBody>
@@ -14441,7 +15128,7 @@
                 </a:solidFill>
                 <a:latin typeface="Calibri"/>
               </a:rPr>
-              <a:t>API error*</a:t>
+              <a:t>classifier: API_ERR</a:t>
             </a:r>
           </a:p>
         </p:txBody>
@@ -14569,7 +15256,7 @@
                 </a:solidFill>
                 <a:latin typeface="Calibri"/>
               </a:rPr>
-              <a:t>needs manual ID**</a:t>
+              <a:t>SKIPPED</a:t>
             </a:r>
           </a:p>
         </p:txBody>
@@ -14718,7 +15405,7 @@
                 </a:solidFill>
                 <a:latin typeface="Calibri"/>
               </a:rPr>
-              <a:t>•  277 tools (OK + empty) produced a validated request/response contract — captured as real input/output examples</a:t>
+              <a:t>•  277 calls labeled OK or EMPTY; these are harvest labels, not end-to-end acceptance results</a:t>
             </a:r>
           </a:p>
           <a:p>
@@ -14756,7 +15443,7 @@
                 </a:solidFill>
                 <a:latin typeface="Calibri"/>
               </a:rPr>
-              <a:t>•  * API errors are mostly the ambiguous {id} resolved to a device UUID where a different entity (image/site/report) was expected</a:t>
+              <a:t>•  Generic argument resolution can choose the wrong entity type; failures require individual investigation</a:t>
             </a:r>
           </a:p>
           <a:p>
@@ -14775,7 +15462,7 @@
                 </a:solidFill>
                 <a:latin typeface="Calibri"/>
               </a:rPr>
-              <a:t>•  ** Skipped tools need IDs not present in the lab (template, report, execution, profile) — their required inputs are documented</a:t>
+              <a:t>•  77 tools were not called because required inputs were unresolved; no success claim for those tools</a:t>
             </a:r>
           </a:p>
           <a:p>
@@ -14794,7 +15481,7 @@
                 </a:solidFill>
                 <a:latin typeface="Calibri"/>
               </a:rPr>
-              <a:t>•  Full appendix: get-tools-evidence.md (per-tool inputs + output samples)</a:t>
+              <a:t>•  Appendix samples may be truncated; use live schemas and dated acceptance evidence</a:t>
             </a:r>
           </a:p>
         </p:txBody>
@@ -14836,7 +15523,7 @@
                 </a:solidFill>
                 <a:latin typeface="Calibri"/>
               </a:rPr>
-              <a:t>Catalyst Center MCP — Switching Management  |  Technical Marketing  |  Validated on CatC 2.3.7.11</a:t>
+              <a:t>Catalyst Center MCP — Switching Management  |  Technical Marketing  |  Lab evidence: CatC 2.3.7.11</a:t>
             </a:r>
           </a:p>
         </p:txBody>
@@ -16220,7 +16907,7 @@
                 </a:solidFill>
                 <a:latin typeface="Calibri"/>
               </a:rPr>
-              <a:t>Bundled but returns HTTP 404 on 2.3.7.11</a:t>
+              <a:t>HTTP 404 observed in this lab; cause not established</a:t>
             </a:r>
           </a:p>
         </p:txBody>
@@ -16262,7 +16949,7 @@
                 </a:solidFill>
                 <a:latin typeface="Calibri"/>
               </a:rPr>
-              <a:t>Catalyst Center MCP — Switching Management  |  Technical Marketing  |  Validated on CatC 2.3.7.11</a:t>
+              <a:t>Catalyst Center MCP — Switching Management  |  Technical Marketing  |  Lab evidence: CatC 2.3.7.11</a:t>
             </a:r>
           </a:p>
         </p:txBody>

</xml_diff>